<commit_message>
Update opaque-selling conference slides
</commit_message>
<xml_diff>
--- a/files/Opaque-Selling-Conference-Slides.pptx
+++ b/files/Opaque-Selling-Conference-Slides.pptx
@@ -3038,7 +3038,14 @@
               </a:defRPr>
             </a:pPr>
             <a:r>
-              <a:t>20-MINUTE CONFERENCE TALK</a:t>
+              <a:t>2</a:t>
+            </a:r>
+            <a:r>
+              <a:rPr lang="en-US"/>
+              <a:t>5</a:t>
+            </a:r>
+            <a:r>
+              <a:t>-MINUTE CONFERENCE TALK</a:t>
             </a:r>
           </a:p>
         </p:txBody>
@@ -6923,8 +6930,8 @@
         </p:nvSpPr>
         <p:spPr>
           <a:xfrm>
-            <a:off x="781050" y="3581400"/>
-            <a:ext cx="6124575" cy="523875"/>
+            <a:off x="536575" y="3581400"/>
+            <a:ext cx="6616700" cy="523875"/>
           </a:xfrm>
           <a:prstGeom prst="rect">
             <a:avLst/>
@@ -16847,7 +16854,7 @@
         <p:spPr>
           <a:xfrm>
             <a:off x="476250" y="1447800"/>
-            <a:ext cx="7239000" cy="561975"/>
+            <a:ext cx="7073900" cy="561975"/>
           </a:xfrm>
           <a:prstGeom prst="rect">
             <a:avLst/>
@@ -16874,7 +16881,7 @@
         <p:spPr>
           <a:xfrm>
             <a:off x="533400" y="1581150"/>
-            <a:ext cx="6858000" cy="323850"/>
+            <a:ext cx="9088120" cy="323850"/>
           </a:xfrm>
           <a:prstGeom prst="rect">
             <a:avLst/>
@@ -28517,15 +28524,15 @@
         <p:spPr>
           <a:xfrm>
             <a:off x="6629400" y="2724150"/>
-            <a:ext cx="4457700" cy="276225"/>
-          </a:xfrm>
-          <a:prstGeom prst="rect">
-            <a:avLst/>
-          </a:prstGeom>
-        </p:spPr>
-        <p:txBody>
-          <a:bodyPr wrap="square" lIns="0" tIns="0" rIns="0" bIns="0" anchor="t">
-            <a:normAutofit fontScale="99174"/>
+            <a:ext cx="4648200" cy="276225"/>
+          </a:xfrm>
+          <a:prstGeom prst="rect">
+            <a:avLst/>
+          </a:prstGeom>
+        </p:spPr>
+        <p:txBody>
+          <a:bodyPr wrap="square" lIns="0" tIns="0" rIns="0" bIns="0" anchor="t">
+            <a:normAutofit/>
           </a:bodyPr>
           <a:lstStyle/>
           <a:p>
@@ -28875,8 +28882,8 @@
         </p:nvSpPr>
         <p:spPr>
           <a:xfrm>
-            <a:off x="6629400" y="4419600"/>
-            <a:ext cx="4457700" cy="400050"/>
+            <a:off x="6628765" y="4419600"/>
+            <a:ext cx="4458335" cy="400050"/>
           </a:xfrm>
           <a:prstGeom prst="rect">
             <a:avLst/>
@@ -28888,7 +28895,7 @@
           </a:bodyPr>
           <a:lstStyle/>
           <a:p>
-            <a:pPr algn="ctr">
+            <a:pPr algn="l">
               <a:defRPr sz="1575" b="1" i="0">
                 <a:solidFill>
                   <a:srgbClr val="FFFFFF"/>
@@ -32127,15 +32134,15 @@
         <p:spPr>
           <a:xfrm>
             <a:off x="781050" y="4000500"/>
-            <a:ext cx="3000375" cy="266700"/>
-          </a:xfrm>
-          <a:prstGeom prst="rect">
-            <a:avLst/>
-          </a:prstGeom>
-        </p:spPr>
-        <p:txBody>
-          <a:bodyPr wrap="square" lIns="0" tIns="0" rIns="0" bIns="0" anchor="t">
-            <a:normAutofit fontScale="98092"/>
+            <a:ext cx="3225800" cy="266700"/>
+          </a:xfrm>
+          <a:prstGeom prst="rect">
+            <a:avLst/>
+          </a:prstGeom>
+        </p:spPr>
+        <p:txBody>
+          <a:bodyPr wrap="square" lIns="0" tIns="0" rIns="0" bIns="0" anchor="t">
+            <a:normAutofit/>
           </a:bodyPr>
           <a:lstStyle/>
           <a:p>
@@ -32167,15 +32174,15 @@
         <p:spPr>
           <a:xfrm>
             <a:off x="781050" y="4410075"/>
-            <a:ext cx="3333750" cy="266700"/>
-          </a:xfrm>
-          <a:prstGeom prst="rect">
-            <a:avLst/>
-          </a:prstGeom>
-        </p:spPr>
-        <p:txBody>
-          <a:bodyPr wrap="square" lIns="0" tIns="0" rIns="0" bIns="0" anchor="t">
-            <a:normAutofit fontScale="96982"/>
+            <a:ext cx="3561080" cy="266700"/>
+          </a:xfrm>
+          <a:prstGeom prst="rect">
+            <a:avLst/>
+          </a:prstGeom>
+        </p:spPr>
+        <p:txBody>
+          <a:bodyPr wrap="square" lIns="0" tIns="0" rIns="0" bIns="0" anchor="t">
+            <a:normAutofit/>
           </a:bodyPr>
           <a:lstStyle/>
           <a:p>
@@ -32257,46 +32264,6 @@
             </a:pPr>
             <a:r>
               <a:t>CHOICE VERSUS FULFILLMENT</a:t>
-            </a:r>
-          </a:p>
-        </p:txBody>
-      </p:sp>
-      <p:sp>
-        <p:nvSpPr>
-          <p:cNvPr id="12" name="矩形 11"/>
-          <p:cNvSpPr>
-            <a:spLocks noGrp="1"/>
-          </p:cNvSpPr>
-          <p:nvPr/>
-        </p:nvSpPr>
-        <p:spPr>
-          <a:xfrm>
-            <a:off x="8305800" y="1724025"/>
-            <a:ext cx="1905000" cy="285750"/>
-          </a:xfrm>
-          <a:prstGeom prst="rect">
-            <a:avLst/>
-          </a:prstGeom>
-        </p:spPr>
-        <p:txBody>
-          <a:bodyPr wrap="square" lIns="0" tIns="0" rIns="0" bIns="0" anchor="t">
-            <a:normAutofit/>
-          </a:bodyPr>
-          <a:lstStyle/>
-          <a:p>
-            <a:pPr algn="l">
-              <a:buNone/>
-              <a:defRPr sz="1650" b="1" i="0">
-                <a:solidFill>
-                  <a:srgbClr val="17191C"/>
-                </a:solidFill>
-                <a:latin typeface="Arial" panose="020B0604020202020204"/>
-                <a:ea typeface="Arial" panose="020B0604020202020204"/>
-                <a:cs typeface="Arial" panose="020B0604020202020204"/>
-              </a:defRPr>
-            </a:pPr>
-            <a:r>
-              <a:t>Demand origin</a:t>
             </a:r>
           </a:p>
         </p:txBody>
@@ -32680,7 +32647,7 @@
         </p:nvSpPr>
         <p:spPr>
           <a:xfrm>
-            <a:off x="8248650" y="1981200"/>
+            <a:off x="8256270" y="1968500"/>
             <a:ext cx="3000375" cy="2057400"/>
           </a:xfrm>
           <a:prstGeom prst="rect">

</xml_diff>